<commit_message>
收工：QuantImmuBench HLAthena 第9工具收尾——续跑补全266/336(逐肽覆盖100/101)+merge 9tools+近随机(AUC0.51/ρ0.08 n.s.)印证提呈≠免疫原性+PPT17页/Word附录(presentation proxy单列不并比)
- 纠Entry HLA「336完整」=工具故障期乱码误读，实166/336；根因bash语法该环境失败需纯python路径
- 续跑2轮-P10(用户拍板)捞回100 chunk，剩70=len8登录节点cgroup内存kill(proxy不值过度工程)
- merge_metrics_9tools.py内置8工具复现验证口径对齐(max|dAUC|0.0136)
- HLAthena按袁老师分工属李紫晨，本窗超额补全已标注

Co-Authored-By: Claude Opus 4.8 <noreply@anthropic.com>
</commit_message>
<xml_diff>
--- a/project/meeting/QuantImmuBench/QuantImmuBench_最终交付_2026-06-24.pptx
+++ b/project/meeting/QuantImmuBench/QuantImmuBench_最终交付_2026-06-24.pptx
@@ -21,9 +21,10 @@
     <p:sldId id="269" r:id="rId15"/>
     <p:sldId id="270" r:id="rId16"/>
     <p:sldId id="271" r:id="rId17"/>
+    <p:sldId id="272" r:id="rId18"/>
   </p:sldIdLst>
   <p:notesMasterIdLst>
-    <p:notesMasterId r:id="rId18"/>
+    <p:notesMasterId r:id="rId19"/>
   </p:notesMasterIdLst>
   <p:sldSz cx="12192000" cy="6858000"/>
   <p:notesSz cx="6858000" cy="12192000"/>
@@ -1157,6 +1158,94 @@
             <a:fld id="{F7021451-1387-4CA6-816F-3879F97B5CBC}" type="slidenum">
               <a:rPr lang="en-US"/>
               <a:t>16</a:t>
+            </a:fld>
+            <a:endParaRPr lang="en-US"/>
+          </a:p>
+        </p:txBody>
+      </p:sp>
+    </p:spTree>
+    <p:extLst>
+      <p:ext uri="{BB962C8B-B14F-4D97-AF65-F5344CB8AC3E}">
+        <p14:creationId xmlns:p14="http://schemas.microsoft.com/office/powerpoint/2010/main" val="1024086991"/>
+      </p:ext>
+    </p:extLst>
+  </p:cSld>
+  <p:clrMapOvr>
+    <a:masterClrMapping/>
+  </p:clrMapOvr>
+</p:notes>
+</file>
+
+<file path=ppt/notesSlides/notesSlide17.xml><?xml version="1.0" encoding="utf-8"?>
+<p:notes xmlns:a="http://schemas.openxmlformats.org/drawingml/2006/main" xmlns:r="http://schemas.openxmlformats.org/officeDocument/2006/relationships" xmlns:p="http://schemas.openxmlformats.org/presentationml/2006/main">
+  <p:cSld>
+    <p:spTree>
+      <p:nvGrpSpPr>
+        <p:cNvPr id="1" name=""/>
+        <p:cNvGrpSpPr/>
+        <p:nvPr/>
+      </p:nvGrpSpPr>
+      <p:grpSpPr>
+        <a:xfrm>
+          <a:off x="0" y="0"/>
+          <a:ext cx="0" cy="0"/>
+          <a:chOff x="0" y="0"/>
+          <a:chExt cx="0" cy="0"/>
+        </a:xfrm>
+      </p:grpSpPr>
+      <p:sp>
+        <p:nvSpPr>
+          <p:cNvPr id="2" name="Slide Image Placeholder 1"/>
+          <p:cNvSpPr>
+            <a:spLocks noGrp="1" noRot="1" noChangeAspect="1"/>
+          </p:cNvSpPr>
+          <p:nvPr>
+            <p:ph type="sldImg"/>
+          </p:nvPr>
+        </p:nvSpPr>
+        <p:spPr/>
+      </p:sp>
+      <p:sp>
+        <p:nvSpPr>
+          <p:cNvPr id="3" name="Notes Placeholder 2"/>
+          <p:cNvSpPr>
+            <a:spLocks noGrp="1"/>
+          </p:cNvSpPr>
+          <p:nvPr>
+            <p:ph type="body" idx="1"/>
+          </p:nvPr>
+        </p:nvSpPr>
+        <p:spPr/>
+        <p:txBody>
+          <a:bodyPr/>
+          <a:lstStyle/>
+          <a:p>
+            <a:r>
+              <a:rPr lang="en-US" dirty="0"/>
+              <a:t/>
+            </a:r>
+            <a:endParaRPr lang="en-US" dirty="0"/>
+          </a:p>
+        </p:txBody>
+      </p:sp>
+      <p:sp>
+        <p:nvSpPr>
+          <p:cNvPr id="4" name="Slide Number Placeholder 3"/>
+          <p:cNvSpPr>
+            <a:spLocks noGrp="1"/>
+          </p:cNvSpPr>
+          <p:nvPr>
+            <p:ph type="sldNum" sz="quarter" idx="10"/>
+          </p:nvPr>
+        </p:nvSpPr>
+        <p:spPr/>
+        <p:txBody>
+          <a:bodyPr/>
+          <a:lstStyle/>
+          <a:p>
+            <a:fld id="{F7021451-1387-4CA6-816F-3879F97B5CBC}" type="slidenum">
+              <a:rPr lang="en-US"/>
+              <a:t>17</a:t>
             </a:fld>
             <a:endParaRPr lang="en-US"/>
           </a:p>
@@ -6873,6 +6962,27 @@
           </a:p>
           <a:p>
             <a:pPr marL="177800" indent="-177800">
+              <a:spcAft>
+                <a:spcPts val="700"/>
+              </a:spcAft>
+              <a:buSzPct val="100000"/>
+              <a:buChar char="•"/>
+            </a:pPr>
+            <a:r>
+              <a:rPr lang="en-US" sz="1300" dirty="0">
+                <a:solidFill>
+                  <a:srgbClr val="FFFFFF"/>
+                </a:solidFill>
+                <a:latin typeface="Microsoft YaHei" pitchFamily="34" charset="0"/>
+                <a:ea typeface="Microsoft YaHei" pitchFamily="34" charset="-122"/>
+                <a:cs typeface="Microsoft YaHei" pitchFamily="34" charset="-120"/>
+              </a:rPr>
+              <a:t>第9工具 HLAthena (presentation proxy) 超额补全：ELISpot 上近随机 (AUC 0.51/ρ 0.08 n.s.)，印证提呈≠免疫原性，单列不并比</a:t>
+            </a:r>
+            <a:endParaRPr lang="en-US" sz="1300" dirty="0"/>
+          </a:p>
+          <a:p>
+            <a:pPr marL="177800" indent="-177800">
               <a:buSzPct val="100000"/>
               <a:buChar char="•"/>
             </a:pPr>
@@ -7581,6 +7691,1253 @@
               <a:t>数据真源：本地 ~/quantimmu/ + HPC /gpfs/.../quantimmu/ · 数字经 csv 三方核对 0 drift · 逐工具 4 类信息见 TOOLS/*.md</a:t>
             </a:r>
             <a:endParaRPr lang="en-US" sz="950" dirty="0"/>
+          </a:p>
+        </p:txBody>
+      </p:sp>
+    </p:spTree>
+  </p:cSld>
+  <p:clrMapOvr>
+    <a:masterClrMapping/>
+  </p:clrMapOvr>
+</p:sld>
+</file>
+
+<file path=ppt/slides/slide17.xml><?xml version="1.0" encoding="utf-8"?>
+<p:sld xmlns:a="http://schemas.openxmlformats.org/drawingml/2006/main" xmlns:r="http://schemas.openxmlformats.org/officeDocument/2006/relationships" xmlns:p="http://schemas.openxmlformats.org/presentationml/2006/main">
+  <p:cSld name="Slide 17">
+    <p:bg>
+      <p:bgPr>
+        <a:solidFill>
+          <a:srgbClr val="F2F7F7"/>
+        </a:solidFill>
+      </p:bgPr>
+    </p:bg>
+    <p:spTree>
+      <p:nvGrpSpPr>
+        <p:cNvPr id="1" name=""/>
+        <p:cNvGrpSpPr/>
+        <p:nvPr/>
+      </p:nvGrpSpPr>
+      <p:grpSpPr>
+        <a:xfrm>
+          <a:off x="0" y="0"/>
+          <a:ext cx="0" cy="0"/>
+          <a:chOff x="0" y="0"/>
+          <a:chExt cx="0" cy="0"/>
+        </a:xfrm>
+      </p:grpSpPr>
+      <p:sp>
+        <p:nvSpPr>
+          <p:cNvPr id="2" name="Shape 0"/>
+          <p:cNvSpPr/>
+          <p:nvPr/>
+        </p:nvSpPr>
+        <p:spPr>
+          <a:xfrm>
+            <a:off x="0" y="0"/>
+            <a:ext cx="256032" cy="6858000"/>
+          </a:xfrm>
+          <a:prstGeom prst="rect">
+            <a:avLst/>
+          </a:prstGeom>
+          <a:solidFill>
+            <a:srgbClr val="C9743D"/>
+          </a:solidFill>
+          <a:ln/>
+        </p:spPr>
+      </p:sp>
+      <p:sp>
+        <p:nvSpPr>
+          <p:cNvPr id="3" name="Text 1"/>
+          <p:cNvSpPr/>
+          <p:nvPr/>
+        </p:nvSpPr>
+        <p:spPr>
+          <a:xfrm>
+            <a:off x="640080" y="384048"/>
+            <a:ext cx="10058400" cy="274320"/>
+          </a:xfrm>
+          <a:prstGeom prst="rect">
+            <a:avLst/>
+          </a:prstGeom>
+          <a:noFill/>
+          <a:ln/>
+        </p:spPr>
+        <p:txBody>
+          <a:bodyPr wrap="square" lIns="0" tIns="0" rIns="0" bIns="0" rtlCol="0" anchor="ctr"/>
+          <a:lstStyle/>
+          <a:p>
+            <a:pPr indent="0" marL="0">
+              <a:buNone/>
+            </a:pPr>
+            <a:r>
+              <a:rPr lang="en-US" sz="1200" b="1" spc="300" kern="0" dirty="0">
+                <a:solidFill>
+                  <a:srgbClr val="C9743D"/>
+                </a:solidFill>
+                <a:latin typeface="Microsoft YaHei" pitchFamily="34" charset="0"/>
+                <a:ea typeface="Microsoft YaHei" pitchFamily="34" charset="-122"/>
+                <a:cs typeface="Microsoft YaHei" pitchFamily="34" charset="-120"/>
+              </a:rPr>
+              <a:t>补充 · 第 9 工具</a:t>
+            </a:r>
+            <a:endParaRPr lang="en-US" sz="1200" dirty="0"/>
+          </a:p>
+        </p:txBody>
+      </p:sp>
+      <p:sp>
+        <p:nvSpPr>
+          <p:cNvPr id="4" name="Text 2"/>
+          <p:cNvSpPr/>
+          <p:nvPr/>
+        </p:nvSpPr>
+        <p:spPr>
+          <a:xfrm>
+            <a:off x="640080" y="658368"/>
+            <a:ext cx="10972800" cy="640080"/>
+          </a:xfrm>
+          <a:prstGeom prst="rect">
+            <a:avLst/>
+          </a:prstGeom>
+          <a:noFill/>
+          <a:ln/>
+        </p:spPr>
+        <p:txBody>
+          <a:bodyPr wrap="square" lIns="0" tIns="0" rIns="0" bIns="0" rtlCol="0" anchor="ctr"/>
+          <a:lstStyle/>
+          <a:p>
+            <a:pPr indent="0" marL="0">
+              <a:buNone/>
+            </a:pPr>
+            <a:r>
+              <a:rPr lang="en-US" sz="2800" b="1" dirty="0">
+                <a:solidFill>
+                  <a:srgbClr val="16323A"/>
+                </a:solidFill>
+                <a:latin typeface="Microsoft YaHei" pitchFamily="34" charset="0"/>
+                <a:ea typeface="Microsoft YaHei" pitchFamily="34" charset="-122"/>
+                <a:cs typeface="Microsoft YaHei" pitchFamily="34" charset="-120"/>
+              </a:rPr>
+              <a:t>HLAthena = presentation proxy，额外评测（presentation≠immunogenicity，不并入 8 工具比较）</a:t>
+            </a:r>
+            <a:endParaRPr lang="en-US" sz="2800" dirty="0"/>
+          </a:p>
+        </p:txBody>
+      </p:sp>
+      <p:sp>
+        <p:nvSpPr>
+          <p:cNvPr id="5" name="Shape 3"/>
+          <p:cNvSpPr/>
+          <p:nvPr/>
+        </p:nvSpPr>
+        <p:spPr>
+          <a:xfrm>
+            <a:off x="640080" y="1627632"/>
+            <a:ext cx="6858000" cy="4617720"/>
+          </a:xfrm>
+          <a:prstGeom prst="rect">
+            <a:avLst/>
+          </a:prstGeom>
+          <a:solidFill>
+            <a:srgbClr val="FFFFFF"/>
+          </a:solidFill>
+          <a:ln w="12700">
+            <a:solidFill>
+              <a:srgbClr val="D5E3E4"/>
+            </a:solidFill>
+            <a:prstDash val="solid"/>
+          </a:ln>
+          <a:effectLst>
+            <a:outerShdw sx="100000" sy="100000" kx="0" ky="0" algn="bl" rotWithShape="0" blurRad="114300" dist="38100" dir="8100000">
+              <a:srgbClr val="0B3C49">
+                <a:alpha val="12000"/>
+              </a:srgbClr>
+            </a:outerShdw>
+          </a:effectLst>
+        </p:spPr>
+      </p:sp>
+      <p:sp>
+        <p:nvSpPr>
+          <p:cNvPr id="6" name="Text 4"/>
+          <p:cNvSpPr/>
+          <p:nvPr/>
+        </p:nvSpPr>
+        <p:spPr>
+          <a:xfrm>
+            <a:off x="868680" y="1783080"/>
+            <a:ext cx="6400800" cy="365760"/>
+          </a:xfrm>
+          <a:prstGeom prst="rect">
+            <a:avLst/>
+          </a:prstGeom>
+          <a:noFill/>
+          <a:ln/>
+        </p:spPr>
+        <p:txBody>
+          <a:bodyPr wrap="square" lIns="0" tIns="0" rIns="0" bIns="0" rtlCol="0" anchor="ctr"/>
+          <a:lstStyle/>
+          <a:p>
+            <a:pPr indent="0" marL="0">
+              <a:buNone/>
+            </a:pPr>
+            <a:r>
+              <a:rPr lang="en-US" sz="1500" b="1" dirty="0">
+                <a:solidFill>
+                  <a:srgbClr val="0B3C49"/>
+                </a:solidFill>
+                <a:latin typeface="Microsoft YaHei" pitchFamily="34" charset="0"/>
+                <a:ea typeface="Microsoft YaHei" pitchFamily="34" charset="-122"/>
+                <a:cs typeface="Microsoft YaHei" pitchFamily="34" charset="-120"/>
+              </a:rPr>
+              <a:t>ELISpot benchmark 结果（DS2，n_pep=100/101）</a:t>
+            </a:r>
+            <a:endParaRPr lang="en-US" sz="1500" dirty="0"/>
+          </a:p>
+        </p:txBody>
+      </p:sp>
+      <p:sp>
+        <p:nvSpPr>
+          <p:cNvPr id="7" name="Shape 5"/>
+          <p:cNvSpPr/>
+          <p:nvPr/>
+        </p:nvSpPr>
+        <p:spPr>
+          <a:xfrm>
+            <a:off x="868680" y="2286000"/>
+            <a:ext cx="6400800" cy="566928"/>
+          </a:xfrm>
+          <a:prstGeom prst="rect">
+            <a:avLst/>
+          </a:prstGeom>
+          <a:solidFill>
+            <a:srgbClr val="F7FAFA"/>
+          </a:solidFill>
+          <a:ln w="12700">
+            <a:solidFill>
+              <a:srgbClr val="D5E3E4"/>
+            </a:solidFill>
+            <a:prstDash val="solid"/>
+          </a:ln>
+        </p:spPr>
+      </p:sp>
+      <p:sp>
+        <p:nvSpPr>
+          <p:cNvPr id="8" name="Shape 6"/>
+          <p:cNvSpPr/>
+          <p:nvPr/>
+        </p:nvSpPr>
+        <p:spPr>
+          <a:xfrm>
+            <a:off x="868680" y="2286000"/>
+            <a:ext cx="73152" cy="566928"/>
+          </a:xfrm>
+          <a:prstGeom prst="rect">
+            <a:avLst/>
+          </a:prstGeom>
+          <a:solidFill>
+            <a:srgbClr val="B23A48"/>
+          </a:solidFill>
+          <a:ln/>
+        </p:spPr>
+      </p:sp>
+      <p:sp>
+        <p:nvSpPr>
+          <p:cNvPr id="9" name="Text 7"/>
+          <p:cNvSpPr/>
+          <p:nvPr/>
+        </p:nvSpPr>
+        <p:spPr>
+          <a:xfrm>
+            <a:off x="1051560" y="2340864"/>
+            <a:ext cx="3017520" cy="457200"/>
+          </a:xfrm>
+          <a:prstGeom prst="rect">
+            <a:avLst/>
+          </a:prstGeom>
+          <a:noFill/>
+          <a:ln/>
+        </p:spPr>
+        <p:txBody>
+          <a:bodyPr wrap="square" lIns="0" tIns="0" rIns="0" bIns="0" rtlCol="0" anchor="ctr"/>
+          <a:lstStyle/>
+          <a:p>
+            <a:pPr indent="0" marL="0">
+              <a:buNone/>
+            </a:pPr>
+            <a:r>
+              <a:rPr lang="en-US" sz="1150" b="1" dirty="0">
+                <a:solidFill>
+                  <a:srgbClr val="16323A"/>
+                </a:solidFill>
+                <a:latin typeface="Microsoft YaHei" pitchFamily="34" charset="0"/>
+                <a:ea typeface="Microsoft YaHei" pitchFamily="34" charset="-122"/>
+                <a:cs typeface="Microsoft YaHei" pitchFamily="34" charset="-120"/>
+              </a:rPr>
+              <a:t>AUC-ROC (max, &gt;0)</a:t>
+            </a:r>
+            <a:endParaRPr lang="en-US" sz="1150" dirty="0"/>
+          </a:p>
+        </p:txBody>
+      </p:sp>
+      <p:sp>
+        <p:nvSpPr>
+          <p:cNvPr id="10" name="Text 8"/>
+          <p:cNvSpPr/>
+          <p:nvPr/>
+        </p:nvSpPr>
+        <p:spPr>
+          <a:xfrm>
+            <a:off x="4114800" y="2340864"/>
+            <a:ext cx="1188720" cy="457200"/>
+          </a:xfrm>
+          <a:prstGeom prst="rect">
+            <a:avLst/>
+          </a:prstGeom>
+          <a:noFill/>
+          <a:ln/>
+        </p:spPr>
+        <p:txBody>
+          <a:bodyPr wrap="square" lIns="0" tIns="0" rIns="0" bIns="0" rtlCol="0" anchor="ctr"/>
+          <a:lstStyle/>
+          <a:p>
+            <a:pPr algn="ctr" indent="0" marL="0">
+              <a:buNone/>
+            </a:pPr>
+            <a:r>
+              <a:rPr lang="en-US" sz="1400" b="1" dirty="0">
+                <a:solidFill>
+                  <a:srgbClr val="B23A48"/>
+                </a:solidFill>
+                <a:latin typeface="Microsoft YaHei" pitchFamily="34" charset="0"/>
+                <a:ea typeface="Microsoft YaHei" pitchFamily="34" charset="-122"/>
+                <a:cs typeface="Microsoft YaHei" pitchFamily="34" charset="-120"/>
+              </a:rPr>
+              <a:t>0.509</a:t>
+            </a:r>
+            <a:endParaRPr lang="en-US" sz="1400" dirty="0"/>
+          </a:p>
+        </p:txBody>
+      </p:sp>
+      <p:sp>
+        <p:nvSpPr>
+          <p:cNvPr id="11" name="Text 9"/>
+          <p:cNvSpPr/>
+          <p:nvPr/>
+        </p:nvSpPr>
+        <p:spPr>
+          <a:xfrm>
+            <a:off x="5349240" y="2340864"/>
+            <a:ext cx="1828800" cy="457200"/>
+          </a:xfrm>
+          <a:prstGeom prst="rect">
+            <a:avLst/>
+          </a:prstGeom>
+          <a:noFill/>
+          <a:ln/>
+        </p:spPr>
+        <p:txBody>
+          <a:bodyPr wrap="square" lIns="0" tIns="0" rIns="0" bIns="0" rtlCol="0" anchor="ctr"/>
+          <a:lstStyle/>
+          <a:p>
+            <a:pPr indent="0" marL="0">
+              <a:buNone/>
+            </a:pPr>
+            <a:r>
+              <a:rPr lang="en-US" sz="1000" i="1" dirty="0">
+                <a:solidFill>
+                  <a:srgbClr val="5E7B83"/>
+                </a:solidFill>
+                <a:latin typeface="Microsoft YaHei" pitchFamily="34" charset="0"/>
+                <a:ea typeface="Microsoft YaHei" pitchFamily="34" charset="-122"/>
+                <a:cs typeface="Microsoft YaHei" pitchFamily="34" charset="-120"/>
+              </a:rPr>
+              <a:t>≈ 随机 (0.5)</a:t>
+            </a:r>
+            <a:endParaRPr lang="en-US" sz="1000" dirty="0"/>
+          </a:p>
+        </p:txBody>
+      </p:sp>
+      <p:sp>
+        <p:nvSpPr>
+          <p:cNvPr id="12" name="Shape 10"/>
+          <p:cNvSpPr/>
+          <p:nvPr/>
+        </p:nvSpPr>
+        <p:spPr>
+          <a:xfrm>
+            <a:off x="868680" y="2944368"/>
+            <a:ext cx="6400800" cy="566928"/>
+          </a:xfrm>
+          <a:prstGeom prst="rect">
+            <a:avLst/>
+          </a:prstGeom>
+          <a:solidFill>
+            <a:srgbClr val="F7FAFA"/>
+          </a:solidFill>
+          <a:ln w="12700">
+            <a:solidFill>
+              <a:srgbClr val="D5E3E4"/>
+            </a:solidFill>
+            <a:prstDash val="solid"/>
+          </a:ln>
+        </p:spPr>
+      </p:sp>
+      <p:sp>
+        <p:nvSpPr>
+          <p:cNvPr id="13" name="Shape 11"/>
+          <p:cNvSpPr/>
+          <p:nvPr/>
+        </p:nvSpPr>
+        <p:spPr>
+          <a:xfrm>
+            <a:off x="868680" y="2944368"/>
+            <a:ext cx="73152" cy="566928"/>
+          </a:xfrm>
+          <a:prstGeom prst="rect">
+            <a:avLst/>
+          </a:prstGeom>
+          <a:solidFill>
+            <a:srgbClr val="B23A48"/>
+          </a:solidFill>
+          <a:ln/>
+        </p:spPr>
+      </p:sp>
+      <p:sp>
+        <p:nvSpPr>
+          <p:cNvPr id="14" name="Text 12"/>
+          <p:cNvSpPr/>
+          <p:nvPr/>
+        </p:nvSpPr>
+        <p:spPr>
+          <a:xfrm>
+            <a:off x="1051560" y="2999232"/>
+            <a:ext cx="3017520" cy="457200"/>
+          </a:xfrm>
+          <a:prstGeom prst="rect">
+            <a:avLst/>
+          </a:prstGeom>
+          <a:noFill/>
+          <a:ln/>
+        </p:spPr>
+        <p:txBody>
+          <a:bodyPr wrap="square" lIns="0" tIns="0" rIns="0" bIns="0" rtlCol="0" anchor="ctr"/>
+          <a:lstStyle/>
+          <a:p>
+            <a:pPr indent="0" marL="0">
+              <a:buNone/>
+            </a:pPr>
+            <a:r>
+              <a:rPr lang="en-US" sz="1150" b="1" dirty="0">
+                <a:solidFill>
+                  <a:srgbClr val="16323A"/>
+                </a:solidFill>
+                <a:latin typeface="Microsoft YaHei" pitchFamily="34" charset="0"/>
+                <a:ea typeface="Microsoft YaHei" pitchFamily="34" charset="-122"/>
+                <a:cs typeface="Microsoft YaHei" pitchFamily="34" charset="-120"/>
+              </a:rPr>
+              <a:t>AUC 全聚合×阈值范围</a:t>
+            </a:r>
+            <a:endParaRPr lang="en-US" sz="1150" dirty="0"/>
+          </a:p>
+        </p:txBody>
+      </p:sp>
+      <p:sp>
+        <p:nvSpPr>
+          <p:cNvPr id="15" name="Text 13"/>
+          <p:cNvSpPr/>
+          <p:nvPr/>
+        </p:nvSpPr>
+        <p:spPr>
+          <a:xfrm>
+            <a:off x="4114800" y="2999232"/>
+            <a:ext cx="1188720" cy="457200"/>
+          </a:xfrm>
+          <a:prstGeom prst="rect">
+            <a:avLst/>
+          </a:prstGeom>
+          <a:noFill/>
+          <a:ln/>
+        </p:spPr>
+        <p:txBody>
+          <a:bodyPr wrap="square" lIns="0" tIns="0" rIns="0" bIns="0" rtlCol="0" anchor="ctr"/>
+          <a:lstStyle/>
+          <a:p>
+            <a:pPr algn="ctr" indent="0" marL="0">
+              <a:buNone/>
+            </a:pPr>
+            <a:r>
+              <a:rPr lang="en-US" sz="1400" b="1" dirty="0">
+                <a:solidFill>
+                  <a:srgbClr val="B23A48"/>
+                </a:solidFill>
+                <a:latin typeface="Microsoft YaHei" pitchFamily="34" charset="0"/>
+                <a:ea typeface="Microsoft YaHei" pitchFamily="34" charset="-122"/>
+                <a:cs typeface="Microsoft YaHei" pitchFamily="34" charset="-120"/>
+              </a:rPr>
+              <a:t>0.49 – 0.59</a:t>
+            </a:r>
+            <a:endParaRPr lang="en-US" sz="1400" dirty="0"/>
+          </a:p>
+        </p:txBody>
+      </p:sp>
+      <p:sp>
+        <p:nvSpPr>
+          <p:cNvPr id="16" name="Text 14"/>
+          <p:cNvSpPr/>
+          <p:nvPr/>
+        </p:nvSpPr>
+        <p:spPr>
+          <a:xfrm>
+            <a:off x="5349240" y="2999232"/>
+            <a:ext cx="1828800" cy="457200"/>
+          </a:xfrm>
+          <a:prstGeom prst="rect">
+            <a:avLst/>
+          </a:prstGeom>
+          <a:noFill/>
+          <a:ln/>
+        </p:spPr>
+        <p:txBody>
+          <a:bodyPr wrap="square" lIns="0" tIns="0" rIns="0" bIns="0" rtlCol="0" anchor="ctr"/>
+          <a:lstStyle/>
+          <a:p>
+            <a:pPr indent="0" marL="0">
+              <a:buNone/>
+            </a:pPr>
+            <a:r>
+              <a:rPr lang="en-US" sz="1000" i="1" dirty="0">
+                <a:solidFill>
+                  <a:srgbClr val="5E7B83"/>
+                </a:solidFill>
+                <a:latin typeface="Microsoft YaHei" pitchFamily="34" charset="0"/>
+                <a:ea typeface="Microsoft YaHei" pitchFamily="34" charset="-122"/>
+                <a:cs typeface="Microsoft YaHei" pitchFamily="34" charset="-120"/>
+              </a:rPr>
+              <a:t>无一显著离开随机</a:t>
+            </a:r>
+            <a:endParaRPr lang="en-US" sz="1000" dirty="0"/>
+          </a:p>
+        </p:txBody>
+      </p:sp>
+      <p:sp>
+        <p:nvSpPr>
+          <p:cNvPr id="17" name="Shape 15"/>
+          <p:cNvSpPr/>
+          <p:nvPr/>
+        </p:nvSpPr>
+        <p:spPr>
+          <a:xfrm>
+            <a:off x="868680" y="3602736"/>
+            <a:ext cx="6400800" cy="566928"/>
+          </a:xfrm>
+          <a:prstGeom prst="rect">
+            <a:avLst/>
+          </a:prstGeom>
+          <a:solidFill>
+            <a:srgbClr val="F7FAFA"/>
+          </a:solidFill>
+          <a:ln w="12700">
+            <a:solidFill>
+              <a:srgbClr val="D5E3E4"/>
+            </a:solidFill>
+            <a:prstDash val="solid"/>
+          </a:ln>
+        </p:spPr>
+      </p:sp>
+      <p:sp>
+        <p:nvSpPr>
+          <p:cNvPr id="18" name="Shape 16"/>
+          <p:cNvSpPr/>
+          <p:nvPr/>
+        </p:nvSpPr>
+        <p:spPr>
+          <a:xfrm>
+            <a:off x="868680" y="3602736"/>
+            <a:ext cx="73152" cy="566928"/>
+          </a:xfrm>
+          <a:prstGeom prst="rect">
+            <a:avLst/>
+          </a:prstGeom>
+          <a:solidFill>
+            <a:srgbClr val="C9743D"/>
+          </a:solidFill>
+          <a:ln/>
+        </p:spPr>
+      </p:sp>
+      <p:sp>
+        <p:nvSpPr>
+          <p:cNvPr id="19" name="Text 17"/>
+          <p:cNvSpPr/>
+          <p:nvPr/>
+        </p:nvSpPr>
+        <p:spPr>
+          <a:xfrm>
+            <a:off x="1051560" y="3657600"/>
+            <a:ext cx="3017520" cy="457200"/>
+          </a:xfrm>
+          <a:prstGeom prst="rect">
+            <a:avLst/>
+          </a:prstGeom>
+          <a:noFill/>
+          <a:ln/>
+        </p:spPr>
+        <p:txBody>
+          <a:bodyPr wrap="square" lIns="0" tIns="0" rIns="0" bIns="0" rtlCol="0" anchor="ctr"/>
+          <a:lstStyle/>
+          <a:p>
+            <a:pPr indent="0" marL="0">
+              <a:buNone/>
+            </a:pPr>
+            <a:r>
+              <a:rPr lang="en-US" sz="1150" b="1" dirty="0">
+                <a:solidFill>
+                  <a:srgbClr val="16323A"/>
+                </a:solidFill>
+                <a:latin typeface="Microsoft YaHei" pitchFamily="34" charset="0"/>
+                <a:ea typeface="Microsoft YaHei" pitchFamily="34" charset="-122"/>
+                <a:cs typeface="Microsoft YaHei" pitchFamily="34" charset="-120"/>
+              </a:rPr>
+              <a:t>Spearman ρ (vs SFC)</a:t>
+            </a:r>
+            <a:endParaRPr lang="en-US" sz="1150" dirty="0"/>
+          </a:p>
+        </p:txBody>
+      </p:sp>
+      <p:sp>
+        <p:nvSpPr>
+          <p:cNvPr id="20" name="Text 18"/>
+          <p:cNvSpPr/>
+          <p:nvPr/>
+        </p:nvSpPr>
+        <p:spPr>
+          <a:xfrm>
+            <a:off x="4114800" y="3657600"/>
+            <a:ext cx="1188720" cy="457200"/>
+          </a:xfrm>
+          <a:prstGeom prst="rect">
+            <a:avLst/>
+          </a:prstGeom>
+          <a:noFill/>
+          <a:ln/>
+        </p:spPr>
+        <p:txBody>
+          <a:bodyPr wrap="square" lIns="0" tIns="0" rIns="0" bIns="0" rtlCol="0" anchor="ctr"/>
+          <a:lstStyle/>
+          <a:p>
+            <a:pPr algn="ctr" indent="0" marL="0">
+              <a:buNone/>
+            </a:pPr>
+            <a:r>
+              <a:rPr lang="en-US" sz="1400" b="1" dirty="0">
+                <a:solidFill>
+                  <a:srgbClr val="C9743D"/>
+                </a:solidFill>
+                <a:latin typeface="Microsoft YaHei" pitchFamily="34" charset="0"/>
+                <a:ea typeface="Microsoft YaHei" pitchFamily="34" charset="-122"/>
+                <a:cs typeface="Microsoft YaHei" pitchFamily="34" charset="-120"/>
+              </a:rPr>
+              <a:t>0.08 – 0.15</a:t>
+            </a:r>
+            <a:endParaRPr lang="en-US" sz="1400" dirty="0"/>
+          </a:p>
+        </p:txBody>
+      </p:sp>
+      <p:sp>
+        <p:nvSpPr>
+          <p:cNvPr id="21" name="Text 19"/>
+          <p:cNvSpPr/>
+          <p:nvPr/>
+        </p:nvSpPr>
+        <p:spPr>
+          <a:xfrm>
+            <a:off x="5349240" y="3657600"/>
+            <a:ext cx="1828800" cy="457200"/>
+          </a:xfrm>
+          <a:prstGeom prst="rect">
+            <a:avLst/>
+          </a:prstGeom>
+          <a:noFill/>
+          <a:ln/>
+        </p:spPr>
+        <p:txBody>
+          <a:bodyPr wrap="square" lIns="0" tIns="0" rIns="0" bIns="0" rtlCol="0" anchor="ctr"/>
+          <a:lstStyle/>
+          <a:p>
+            <a:pPr indent="0" marL="0">
+              <a:buNone/>
+            </a:pPr>
+            <a:r>
+              <a:rPr lang="en-US" sz="1000" i="1" dirty="0">
+                <a:solidFill>
+                  <a:srgbClr val="5E7B83"/>
+                </a:solidFill>
+                <a:latin typeface="Microsoft YaHei" pitchFamily="34" charset="0"/>
+                <a:ea typeface="Microsoft YaHei" pitchFamily="34" charset="-122"/>
+                <a:cs typeface="Microsoft YaHei" pitchFamily="34" charset="-120"/>
+              </a:rPr>
+              <a:t>p 全 &gt; 0.12 = 不显著</a:t>
+            </a:r>
+            <a:endParaRPr lang="en-US" sz="1000" dirty="0"/>
+          </a:p>
+        </p:txBody>
+      </p:sp>
+      <p:sp>
+        <p:nvSpPr>
+          <p:cNvPr id="22" name="Shape 20"/>
+          <p:cNvSpPr/>
+          <p:nvPr/>
+        </p:nvSpPr>
+        <p:spPr>
+          <a:xfrm>
+            <a:off x="868680" y="4261104"/>
+            <a:ext cx="6400800" cy="566928"/>
+          </a:xfrm>
+          <a:prstGeom prst="rect">
+            <a:avLst/>
+          </a:prstGeom>
+          <a:solidFill>
+            <a:srgbClr val="F7FAFA"/>
+          </a:solidFill>
+          <a:ln w="12700">
+            <a:solidFill>
+              <a:srgbClr val="D5E3E4"/>
+            </a:solidFill>
+            <a:prstDash val="solid"/>
+          </a:ln>
+        </p:spPr>
+      </p:sp>
+      <p:sp>
+        <p:nvSpPr>
+          <p:cNvPr id="23" name="Shape 21"/>
+          <p:cNvSpPr/>
+          <p:nvPr/>
+        </p:nvSpPr>
+        <p:spPr>
+          <a:xfrm>
+            <a:off x="868680" y="4261104"/>
+            <a:ext cx="73152" cy="566928"/>
+          </a:xfrm>
+          <a:prstGeom prst="rect">
+            <a:avLst/>
+          </a:prstGeom>
+          <a:solidFill>
+            <a:srgbClr val="C9743D"/>
+          </a:solidFill>
+          <a:ln/>
+        </p:spPr>
+      </p:sp>
+      <p:sp>
+        <p:nvSpPr>
+          <p:cNvPr id="24" name="Text 22"/>
+          <p:cNvSpPr/>
+          <p:nvPr/>
+        </p:nvSpPr>
+        <p:spPr>
+          <a:xfrm>
+            <a:off x="1051560" y="4315968"/>
+            <a:ext cx="3017520" cy="457200"/>
+          </a:xfrm>
+          <a:prstGeom prst="rect">
+            <a:avLst/>
+          </a:prstGeom>
+          <a:noFill/>
+          <a:ln/>
+        </p:spPr>
+        <p:txBody>
+          <a:bodyPr wrap="square" lIns="0" tIns="0" rIns="0" bIns="0" rtlCol="0" anchor="ctr"/>
+          <a:lstStyle/>
+          <a:p>
+            <a:pPr indent="0" marL="0">
+              <a:buNone/>
+            </a:pPr>
+            <a:r>
+              <a:rPr lang="en-US" sz="1150" b="1" dirty="0">
+                <a:solidFill>
+                  <a:srgbClr val="16323A"/>
+                </a:solidFill>
+                <a:latin typeface="Microsoft YaHei" pitchFamily="34" charset="0"/>
+                <a:ea typeface="Microsoft YaHei" pitchFamily="34" charset="-122"/>
+                <a:cs typeface="Microsoft YaHei" pitchFamily="34" charset="-120"/>
+              </a:rPr>
+              <a:t>AUPRC (max, &gt;0)</a:t>
+            </a:r>
+            <a:endParaRPr lang="en-US" sz="1150" dirty="0"/>
+          </a:p>
+        </p:txBody>
+      </p:sp>
+      <p:sp>
+        <p:nvSpPr>
+          <p:cNvPr id="25" name="Text 23"/>
+          <p:cNvSpPr/>
+          <p:nvPr/>
+        </p:nvSpPr>
+        <p:spPr>
+          <a:xfrm>
+            <a:off x="4114800" y="4315968"/>
+            <a:ext cx="1188720" cy="457200"/>
+          </a:xfrm>
+          <a:prstGeom prst="rect">
+            <a:avLst/>
+          </a:prstGeom>
+          <a:noFill/>
+          <a:ln/>
+        </p:spPr>
+        <p:txBody>
+          <a:bodyPr wrap="square" lIns="0" tIns="0" rIns="0" bIns="0" rtlCol="0" anchor="ctr"/>
+          <a:lstStyle/>
+          <a:p>
+            <a:pPr algn="ctr" indent="0" marL="0">
+              <a:buNone/>
+            </a:pPr>
+            <a:r>
+              <a:rPr lang="en-US" sz="1400" b="1" dirty="0">
+                <a:solidFill>
+                  <a:srgbClr val="C9743D"/>
+                </a:solidFill>
+                <a:latin typeface="Microsoft YaHei" pitchFamily="34" charset="0"/>
+                <a:ea typeface="Microsoft YaHei" pitchFamily="34" charset="-122"/>
+                <a:cs typeface="Microsoft YaHei" pitchFamily="34" charset="-120"/>
+              </a:rPr>
+              <a:t>0.890</a:t>
+            </a:r>
+            <a:endParaRPr lang="en-US" sz="1400" dirty="0"/>
+          </a:p>
+        </p:txBody>
+      </p:sp>
+      <p:sp>
+        <p:nvSpPr>
+          <p:cNvPr id="26" name="Text 24"/>
+          <p:cNvSpPr/>
+          <p:nvPr/>
+        </p:nvSpPr>
+        <p:spPr>
+          <a:xfrm>
+            <a:off x="5349240" y="4315968"/>
+            <a:ext cx="1828800" cy="457200"/>
+          </a:xfrm>
+          <a:prstGeom prst="rect">
+            <a:avLst/>
+          </a:prstGeom>
+          <a:noFill/>
+          <a:ln/>
+        </p:spPr>
+        <p:txBody>
+          <a:bodyPr wrap="square" lIns="0" tIns="0" rIns="0" bIns="0" rtlCol="0" anchor="ctr"/>
+          <a:lstStyle/>
+          <a:p>
+            <a:pPr indent="0" marL="0">
+              <a:buNone/>
+            </a:pPr>
+            <a:r>
+              <a:rPr lang="en-US" sz="1000" i="1" dirty="0">
+                <a:solidFill>
+                  <a:srgbClr val="5E7B83"/>
+                </a:solidFill>
+                <a:latin typeface="Microsoft YaHei" pitchFamily="34" charset="0"/>
+                <a:ea typeface="Microsoft YaHei" pitchFamily="34" charset="-122"/>
+                <a:cs typeface="Microsoft YaHei" pitchFamily="34" charset="-120"/>
+              </a:rPr>
+              <a:t>base rate 0.89 → 无提升</a:t>
+            </a:r>
+            <a:endParaRPr lang="en-US" sz="1000" dirty="0"/>
+          </a:p>
+        </p:txBody>
+      </p:sp>
+      <p:sp>
+        <p:nvSpPr>
+          <p:cNvPr id="27" name="Shape 25"/>
+          <p:cNvSpPr/>
+          <p:nvPr/>
+        </p:nvSpPr>
+        <p:spPr>
+          <a:xfrm>
+            <a:off x="868680" y="5029200"/>
+            <a:ext cx="6400800" cy="1078992"/>
+          </a:xfrm>
+          <a:prstGeom prst="rect">
+            <a:avLst/>
+          </a:prstGeom>
+          <a:solidFill>
+            <a:srgbClr val="E6F4F1"/>
+          </a:solidFill>
+          <a:ln w="12700">
+            <a:solidFill>
+              <a:srgbClr val="00A896"/>
+            </a:solidFill>
+            <a:prstDash val="solid"/>
+          </a:ln>
+        </p:spPr>
+      </p:sp>
+      <p:sp>
+        <p:nvSpPr>
+          <p:cNvPr id="28" name="Text 26"/>
+          <p:cNvSpPr/>
+          <p:nvPr/>
+        </p:nvSpPr>
+        <p:spPr>
+          <a:xfrm>
+            <a:off x="1051560" y="5084064"/>
+            <a:ext cx="6035040" cy="969264"/>
+          </a:xfrm>
+          <a:prstGeom prst="rect">
+            <a:avLst/>
+          </a:prstGeom>
+          <a:noFill/>
+          <a:ln/>
+        </p:spPr>
+        <p:txBody>
+          <a:bodyPr wrap="square" lIns="0" tIns="0" rIns="0" bIns="0" rtlCol="0" anchor="ctr"/>
+          <a:lstStyle/>
+          <a:p>
+            <a:pPr indent="0" marL="0">
+              <a:lnSpc>
+                <a:spcPct val="104000"/>
+              </a:lnSpc>
+              <a:buNone/>
+            </a:pPr>
+            <a:r>
+              <a:rPr lang="en-US" sz="1200" b="1" dirty="0">
+                <a:solidFill>
+                  <a:srgbClr val="028090"/>
+                </a:solidFill>
+                <a:latin typeface="Microsoft YaHei" pitchFamily="34" charset="0"/>
+                <a:ea typeface="Microsoft YaHei" pitchFamily="34" charset="-122"/>
+                <a:cs typeface="Microsoft YaHei" pitchFamily="34" charset="-120"/>
+              </a:rPr>
+              <a:t>结论：</a:t>
+            </a:r>
+            <a:pPr indent="0" marL="0">
+              <a:lnSpc>
+                <a:spcPct val="104000"/>
+              </a:lnSpc>
+              <a:buNone/>
+            </a:pPr>
+            <a:r>
+              <a:rPr lang="en-US" sz="1100" dirty="0">
+                <a:solidFill>
+                  <a:srgbClr val="16323A"/>
+                </a:solidFill>
+                <a:latin typeface="Microsoft YaHei" pitchFamily="34" charset="0"/>
+                <a:ea typeface="Microsoft YaHei" pitchFamily="34" charset="-122"/>
+                <a:cs typeface="Microsoft YaHei" pitchFamily="34" charset="-120"/>
+              </a:rPr>
+              <a:t>HLAthena 在 ELISpot 免疫原性上近随机 —— 正面印证它的设计定位（预测 MHC-I 提呈，论文明确声明不预测免疫原性）。故作 presentation baseline proxy 单列，</a:t>
+            </a:r>
+            <a:pPr indent="0" marL="0">
+              <a:lnSpc>
+                <a:spcPct val="104000"/>
+              </a:lnSpc>
+              <a:buNone/>
+            </a:pPr>
+            <a:r>
+              <a:rPr lang="en-US" sz="1100" b="1" dirty="0">
+                <a:solidFill>
+                  <a:srgbClr val="0B3C49"/>
+                </a:solidFill>
+                <a:latin typeface="Microsoft YaHei" pitchFamily="34" charset="0"/>
+                <a:ea typeface="Microsoft YaHei" pitchFamily="34" charset="-122"/>
+                <a:cs typeface="Microsoft YaHei" pitchFamily="34" charset="-120"/>
+              </a:rPr>
+              <a:t>不与 8 个免疫原性工具 apples-to-apples 并列。</a:t>
+            </a:r>
+            <a:endParaRPr lang="en-US" sz="1200" dirty="0"/>
+          </a:p>
+        </p:txBody>
+      </p:sp>
+      <p:sp>
+        <p:nvSpPr>
+          <p:cNvPr id="29" name="Shape 27"/>
+          <p:cNvSpPr/>
+          <p:nvPr/>
+        </p:nvSpPr>
+        <p:spPr>
+          <a:xfrm>
+            <a:off x="7680960" y="1627632"/>
+            <a:ext cx="3977640" cy="4617720"/>
+          </a:xfrm>
+          <a:prstGeom prst="rect">
+            <a:avLst/>
+          </a:prstGeom>
+          <a:solidFill>
+            <a:srgbClr val="FFFFFF"/>
+          </a:solidFill>
+          <a:ln w="12700">
+            <a:solidFill>
+              <a:srgbClr val="D5E3E4"/>
+            </a:solidFill>
+            <a:prstDash val="solid"/>
+          </a:ln>
+          <a:effectLst>
+            <a:outerShdw sx="100000" sy="100000" kx="0" ky="0" algn="bl" rotWithShape="0" blurRad="114300" dist="38100" dir="8100000">
+              <a:srgbClr val="0B3C49">
+                <a:alpha val="12000"/>
+              </a:srgbClr>
+            </a:outerShdw>
+          </a:effectLst>
+        </p:spPr>
+      </p:sp>
+      <p:sp>
+        <p:nvSpPr>
+          <p:cNvPr id="30" name="Text 28"/>
+          <p:cNvSpPr/>
+          <p:nvPr/>
+        </p:nvSpPr>
+        <p:spPr>
+          <a:xfrm>
+            <a:off x="7909560" y="1783080"/>
+            <a:ext cx="3566160" cy="365760"/>
+          </a:xfrm>
+          <a:prstGeom prst="rect">
+            <a:avLst/>
+          </a:prstGeom>
+          <a:noFill/>
+          <a:ln/>
+        </p:spPr>
+        <p:txBody>
+          <a:bodyPr wrap="square" lIns="0" tIns="0" rIns="0" bIns="0" rtlCol="0" anchor="ctr"/>
+          <a:lstStyle/>
+          <a:p>
+            <a:pPr indent="0" marL="0">
+              <a:buNone/>
+            </a:pPr>
+            <a:r>
+              <a:rPr lang="en-US" sz="1500" b="1" dirty="0">
+                <a:solidFill>
+                  <a:srgbClr val="C9743D"/>
+                </a:solidFill>
+                <a:latin typeface="Microsoft YaHei" pitchFamily="34" charset="0"/>
+                <a:ea typeface="Microsoft YaHei" pitchFamily="34" charset="-122"/>
+                <a:cs typeface="Microsoft YaHei" pitchFamily="34" charset="-120"/>
+              </a:rPr>
+              <a:t>覆盖度 &amp; 工程诚实</a:t>
+            </a:r>
+            <a:endParaRPr lang="en-US" sz="1500" dirty="0"/>
+          </a:p>
+        </p:txBody>
+      </p:sp>
+      <p:sp>
+        <p:nvSpPr>
+          <p:cNvPr id="31" name="Text 29"/>
+          <p:cNvSpPr/>
+          <p:nvPr/>
+        </p:nvSpPr>
+        <p:spPr>
+          <a:xfrm>
+            <a:off x="7909560" y="2240280"/>
+            <a:ext cx="3566160" cy="3931920"/>
+          </a:xfrm>
+          <a:prstGeom prst="rect">
+            <a:avLst/>
+          </a:prstGeom>
+          <a:noFill/>
+          <a:ln/>
+        </p:spPr>
+        <p:txBody>
+          <a:bodyPr wrap="square" lIns="0" tIns="0" rIns="0" bIns="0" rtlCol="0" anchor="t"/>
+          <a:lstStyle/>
+          <a:p>
+            <a:pPr indent="0" marL="0">
+              <a:lnSpc>
+                <a:spcPct val="105000"/>
+              </a:lnSpc>
+              <a:buNone/>
+            </a:pPr>
+            <a:r>
+              <a:rPr lang="en-US" sz="1150" b="1" dirty="0">
+                <a:solidFill>
+                  <a:srgbClr val="0B3C49"/>
+                </a:solidFill>
+                <a:latin typeface="Microsoft YaHei" pitchFamily="34" charset="0"/>
+                <a:ea typeface="Microsoft YaHei" pitchFamily="34" charset="-122"/>
+                <a:cs typeface="Microsoft YaHei" pitchFamily="34" charset="-120"/>
+              </a:rPr>
+              <a:t>逐肽覆盖 100/101 (98%)</a:t>
+            </a:r>
+            <a:endParaRPr lang="en-US" sz="1150" dirty="0"/>
+          </a:p>
+          <a:p>
+            <a:pPr indent="0" marL="0">
+              <a:lnSpc>
+                <a:spcPct val="105000"/>
+              </a:lnSpc>
+              <a:spcAft>
+                <a:spcPts val="1000"/>
+              </a:spcAft>
+              <a:buNone/>
+            </a:pPr>
+            <a:r>
+              <a:rPr lang="en-US" sz="1050" dirty="0">
+                <a:solidFill>
+                  <a:srgbClr val="16323A"/>
+                </a:solidFill>
+                <a:latin typeface="Microsoft YaHei" pitchFamily="34" charset="0"/>
+                <a:ea typeface="Microsoft YaHei" pitchFamily="34" charset="-122"/>
+                <a:cs typeface="Microsoft YaHei" pitchFamily="34" charset="-120"/>
+              </a:rPr>
+              <a:t>每肽对全 HLA×window 子肽取 max 聚合 → 即便部分子肽缺失，逐肽分稳健。</a:t>
+            </a:r>
+            <a:endParaRPr lang="en-US" sz="1150" dirty="0"/>
+          </a:p>
+          <a:p>
+            <a:pPr indent="0" marL="0">
+              <a:lnSpc>
+                <a:spcPct val="105000"/>
+              </a:lnSpc>
+              <a:buNone/>
+            </a:pPr>
+            <a:r>
+              <a:rPr lang="en-US" sz="1150" b="1" dirty="0">
+                <a:solidFill>
+                  <a:srgbClr val="0B3C49"/>
+                </a:solidFill>
+                <a:latin typeface="Microsoft YaHei" pitchFamily="34" charset="0"/>
+                <a:ea typeface="Microsoft YaHei" pitchFamily="34" charset="-122"/>
+                <a:cs typeface="Microsoft YaHei" pitchFamily="34" charset="-120"/>
+              </a:rPr>
+              <a:t>分块 266/336 完成</a:t>
+            </a:r>
+            <a:endParaRPr lang="en-US" sz="1150" dirty="0"/>
+          </a:p>
+          <a:p>
+            <a:pPr indent="0" marL="0">
+              <a:lnSpc>
+                <a:spcPct val="105000"/>
+              </a:lnSpc>
+              <a:spcAft>
+                <a:spcPts val="1000"/>
+              </a:spcAft>
+              <a:buNone/>
+            </a:pPr>
+            <a:r>
+              <a:rPr lang="en-US" sz="1050" dirty="0">
+                <a:solidFill>
+                  <a:srgbClr val="16323A"/>
+                </a:solidFill>
+                <a:latin typeface="Microsoft YaHei" pitchFamily="34" charset="0"/>
+                <a:ea typeface="Microsoft YaHei" pitchFamily="34" charset="-122"/>
+                <a:cs typeface="Microsoft YaHei" pitchFamily="34" charset="-120"/>
+              </a:rPr>
+              <a:t>HPC 登录节点跑（无专用 CPU qos）；70 个 chunk 多为 length-8 在节点高负载下被 cgroup 内存 kill，未完成。近随机结论不受影响（覆盖已 98%）。</a:t>
+            </a:r>
+            <a:endParaRPr lang="en-US" sz="1150" dirty="0"/>
+          </a:p>
+          <a:p>
+            <a:pPr indent="0" marL="0">
+              <a:lnSpc>
+                <a:spcPct val="105000"/>
+              </a:lnSpc>
+              <a:buNone/>
+            </a:pPr>
+            <a:r>
+              <a:rPr lang="en-US" sz="1150" b="1" dirty="0">
+                <a:solidFill>
+                  <a:srgbClr val="0B3C49"/>
+                </a:solidFill>
+                <a:latin typeface="Microsoft YaHei" pitchFamily="34" charset="0"/>
+                <a:ea typeface="Microsoft YaHei" pitchFamily="34" charset="-122"/>
+                <a:cs typeface="Microsoft YaHei" pitchFamily="34" charset="-120"/>
+              </a:rPr>
+              <a:t>GCS 死锁绕过</a:t>
+            </a:r>
+            <a:endParaRPr lang="en-US" sz="1150" dirty="0"/>
+          </a:p>
+          <a:p>
+            <a:pPr indent="0" marL="0">
+              <a:lnSpc>
+                <a:spcPct val="105000"/>
+              </a:lnSpc>
+              <a:buNone/>
+            </a:pPr>
+            <a:r>
+              <a:rPr lang="en-US" sz="1050" dirty="0">
+                <a:solidFill>
+                  <a:srgbClr val="16323A"/>
+                </a:solidFill>
+                <a:latin typeface="Microsoft YaHei" pitchFamily="34" charset="0"/>
+                <a:ea typeface="Microsoft YaHei" pitchFamily="34" charset="-122"/>
+                <a:cs typeface="Microsoft YaHei" pitchFamily="34" charset="-120"/>
+              </a:rPr>
+              <a:t>镜像空壳运行时拉模型 401 死锁 → 匿名下 65-allele 模型 + patch fetch_models=false 本地挂载跑通。</a:t>
+            </a:r>
+            <a:endParaRPr lang="en-US" sz="1150" dirty="0"/>
+          </a:p>
+        </p:txBody>
+      </p:sp>
+      <p:sp>
+        <p:nvSpPr>
+          <p:cNvPr id="32" name="Text 30"/>
+          <p:cNvSpPr/>
+          <p:nvPr/>
+        </p:nvSpPr>
+        <p:spPr>
+          <a:xfrm>
+            <a:off x="640080" y="6355080"/>
+            <a:ext cx="10972800" cy="365760"/>
+          </a:xfrm>
+          <a:prstGeom prst="rect">
+            <a:avLst/>
+          </a:prstGeom>
+          <a:noFill/>
+          <a:ln/>
+        </p:spPr>
+        <p:txBody>
+          <a:bodyPr wrap="square" lIns="0" tIns="0" rIns="0" bIns="0" rtlCol="0" anchor="t"/>
+          <a:lstStyle/>
+          <a:p>
+            <a:pPr indent="0" marL="0">
+              <a:buNone/>
+            </a:pPr>
+            <a:r>
+              <a:rPr lang="en-US" sz="900" i="1" dirty="0">
+                <a:solidFill>
+                  <a:srgbClr val="5E7B83"/>
+                </a:solidFill>
+                <a:latin typeface="Microsoft YaHei" pitchFamily="34" charset="0"/>
+                <a:ea typeface="Microsoft YaHei" pitchFamily="34" charset="-122"/>
+                <a:cs typeface="Microsoft YaHei" pitchFamily="34" charset="-120"/>
+              </a:rPr>
+              <a:t>数字核 analysis/metrics_ds2_9tools.csv（HLAthena 行）· merge 见 scripts/out/merged_all_tools_9tools.xlsx · ⚠️ HLAthena 按袁老师分工属李紫晨，本评测为余嘉超额补全。</a:t>
+            </a:r>
+            <a:endParaRPr lang="en-US" sz="900" dirty="0"/>
+          </a:p>
+        </p:txBody>
+      </p:sp>
+      <p:sp>
+        <p:nvSpPr>
+          <p:cNvPr id="33" name="Text 31"/>
+          <p:cNvSpPr/>
+          <p:nvPr/>
+        </p:nvSpPr>
+        <p:spPr>
+          <a:xfrm>
+            <a:off x="11457432" y="6400800"/>
+            <a:ext cx="457200" cy="274320"/>
+          </a:xfrm>
+          <a:prstGeom prst="rect">
+            <a:avLst/>
+          </a:prstGeom>
+          <a:noFill/>
+          <a:ln/>
+        </p:spPr>
+        <p:txBody>
+          <a:bodyPr wrap="square" lIns="0" tIns="0" rIns="0" bIns="0" rtlCol="0" anchor="ctr"/>
+          <a:lstStyle/>
+          <a:p>
+            <a:pPr algn="r" indent="0" marL="0">
+              <a:buNone/>
+            </a:pPr>
+            <a:r>
+              <a:rPr lang="en-US" sz="1100" dirty="0">
+                <a:solidFill>
+                  <a:srgbClr val="5E7B83"/>
+                </a:solidFill>
+                <a:latin typeface="Microsoft YaHei" pitchFamily="34" charset="0"/>
+                <a:ea typeface="Microsoft YaHei" pitchFamily="34" charset="-122"/>
+                <a:cs typeface="Microsoft YaHei" pitchFamily="34" charset="-120"/>
+              </a:rPr>
+              <a:t>16</a:t>
+            </a:r>
+            <a:endParaRPr lang="en-US" sz="1100" dirty="0"/>
           </a:p>
         </p:txBody>
       </p:sp>

</xml_diff>